<commit_message>
extraction with gemini input
</commit_message>
<xml_diff>
--- a/NLP_Lecture.pptx
+++ b/NLP_Lecture.pptx
@@ -18,6 +18,45 @@
     <p:sldId id="266" r:id="rId17"/>
     <p:sldId id="267" r:id="rId18"/>
     <p:sldId id="268" r:id="rId19"/>
+    <p:sldId id="269" r:id="rId20"/>
+    <p:sldId id="270" r:id="rId21"/>
+    <p:sldId id="271" r:id="rId22"/>
+    <p:sldId id="272" r:id="rId23"/>
+    <p:sldId id="273" r:id="rId24"/>
+    <p:sldId id="274" r:id="rId25"/>
+    <p:sldId id="275" r:id="rId26"/>
+    <p:sldId id="276" r:id="rId27"/>
+    <p:sldId id="277" r:id="rId28"/>
+    <p:sldId id="278" r:id="rId29"/>
+    <p:sldId id="279" r:id="rId30"/>
+    <p:sldId id="280" r:id="rId31"/>
+    <p:sldId id="281" r:id="rId32"/>
+    <p:sldId id="282" r:id="rId33"/>
+    <p:sldId id="283" r:id="rId34"/>
+    <p:sldId id="284" r:id="rId35"/>
+    <p:sldId id="285" r:id="rId36"/>
+    <p:sldId id="286" r:id="rId37"/>
+    <p:sldId id="287" r:id="rId38"/>
+    <p:sldId id="288" r:id="rId39"/>
+    <p:sldId id="289" r:id="rId40"/>
+    <p:sldId id="290" r:id="rId41"/>
+    <p:sldId id="291" r:id="rId42"/>
+    <p:sldId id="292" r:id="rId43"/>
+    <p:sldId id="293" r:id="rId44"/>
+    <p:sldId id="294" r:id="rId45"/>
+    <p:sldId id="295" r:id="rId46"/>
+    <p:sldId id="296" r:id="rId47"/>
+    <p:sldId id="297" r:id="rId48"/>
+    <p:sldId id="298" r:id="rId49"/>
+    <p:sldId id="299" r:id="rId50"/>
+    <p:sldId id="300" r:id="rId51"/>
+    <p:sldId id="301" r:id="rId52"/>
+    <p:sldId id="302" r:id="rId53"/>
+    <p:sldId id="303" r:id="rId54"/>
+    <p:sldId id="304" r:id="rId55"/>
+    <p:sldId id="305" r:id="rId56"/>
+    <p:sldId id="306" r:id="rId57"/>
+    <p:sldId id="307" r:id="rId58"/>
   </p:sldIdLst>
   <p:sldSz cx="9144000" cy="6858000" type="screen4x3"/>
   <p:notesSz cx="6858000" cy="9144000"/>
@@ -3137,11 +3176,6 @@
           <a:lstStyle/>
           <a:p>
             <a:r>
-              <a:t>A Lecture in 3 Parts</a:t>
-            </a:r>
-          </a:p>
-          <a:p>
-            <a:r>
               <a:t>[Your Name/Institution]</a:t>
             </a:r>
           </a:p>
@@ -3186,7 +3220,7 @@
           <a:lstStyle/>
           <a:p>
             <a:r>
-              <a:t>Real-World Applications</a:t>
+              <a:t>**Slide 2: Introduction to NLP (5 minutes)**</a:t>
             </a:r>
           </a:p>
         </p:txBody>
@@ -3206,54 +3240,6 @@
           <a:bodyPr/>
           <a:lstStyle/>
           <a:p/>
-          <a:p>
-            <a:pPr>
-              <a:defRPr sz="1800"/>
-            </a:pPr>
-            <a:r>
-              <a:t>Chatbots and Virtual Assistants: Siri, Alexa, customer service bots.</a:t>
-            </a:r>
-          </a:p>
-          <a:p>
-            <a:pPr>
-              <a:defRPr sz="1800"/>
-            </a:pPr>
-            <a:r>
-              <a:t>Machine Translation: Google Translate, DeepL.</a:t>
-            </a:r>
-          </a:p>
-          <a:p>
-            <a:pPr>
-              <a:defRPr sz="1800"/>
-            </a:pPr>
-            <a:r>
-              <a:t>Sentiment Analysis: Monitoring social media, analyzing customer reviews.</a:t>
-            </a:r>
-          </a:p>
-          <a:p>
-            <a:pPr>
-              <a:defRPr sz="1800"/>
-            </a:pPr>
-            <a:r>
-              <a:t>Medical Diagnosis Support: Analyzing patient records and medical literature.</a:t>
-            </a:r>
-          </a:p>
-          <a:p>
-            <a:pPr>
-              <a:defRPr sz="1800"/>
-            </a:pPr>
-            <a:r>
-              <a:t>Legal Document Review: Automating the review of legal documents.</a:t>
-            </a:r>
-          </a:p>
-          <a:p>
-            <a:pPr>
-              <a:defRPr sz="1800"/>
-            </a:pPr>
-            <a:r>
-              <a:t>Search Engines: Improving search relevance and understanding user queries.</a:t>
-            </a:r>
-          </a:p>
         </p:txBody>
       </p:sp>
     </p:spTree>
@@ -3290,7 +3276,7 @@
           <a:lstStyle/>
           <a:p>
             <a:r>
-              <a:t>Ethical Considerations</a:t>
+              <a:t>* **Title:** What is Natural Language Processing (NLP)?</a:t>
             </a:r>
           </a:p>
         </p:txBody>
@@ -3310,30 +3296,6 @@
           <a:bodyPr/>
           <a:lstStyle/>
           <a:p/>
-          <a:p>
-            <a:pPr>
-              <a:defRPr sz="1800"/>
-            </a:pPr>
-            <a:r>
-              <a:t>Bias in Data and Models: Addressing biases that lead to unfair or discriminatory outcomes.</a:t>
-            </a:r>
-          </a:p>
-          <a:p>
-            <a:pPr>
-              <a:defRPr sz="1800"/>
-            </a:pPr>
-            <a:r>
-              <a:t>Privacy Concerns: Protecting user data and ensuring responsible use of NLP technologies.</a:t>
-            </a:r>
-          </a:p>
-          <a:p>
-            <a:pPr>
-              <a:defRPr sz="1800"/>
-            </a:pPr>
-            <a:r>
-              <a:t>Misinformation and Manipulation: Preventing the use of NLP for generating fake news.</a:t>
-            </a:r>
-          </a:p>
         </p:txBody>
       </p:sp>
     </p:spTree>
@@ -3370,7 +3332,7 @@
           <a:lstStyle/>
           <a:p>
             <a:r>
-              <a:t>Future Directions</a:t>
+              <a:t>* **Bullet Points:**</a:t>
             </a:r>
           </a:p>
         </p:txBody>
@@ -3390,38 +3352,6 @@
           <a:bodyPr/>
           <a:lstStyle/>
           <a:p/>
-          <a:p>
-            <a:pPr>
-              <a:defRPr sz="1800"/>
-            </a:pPr>
-            <a:r>
-              <a:t>Multimodal NLP: Combining NLP with images and audio.</a:t>
-            </a:r>
-          </a:p>
-          <a:p>
-            <a:pPr>
-              <a:defRPr sz="1800"/>
-            </a:pPr>
-            <a:r>
-              <a:t>Explainable NLP: Making NLP models more transparent and understandable.</a:t>
-            </a:r>
-          </a:p>
-          <a:p>
-            <a:pPr>
-              <a:defRPr sz="1800"/>
-            </a:pPr>
-            <a:r>
-              <a:t>Low-Resource NLP: Developing NLP for languages with limited data.</a:t>
-            </a:r>
-          </a:p>
-          <a:p>
-            <a:pPr>
-              <a:defRPr sz="1800"/>
-            </a:pPr>
-            <a:r>
-              <a:t>Improved Common Sense Reasoning: Enabling NLP systems to reason with common sense knowledge.</a:t>
-            </a:r>
-          </a:p>
         </p:txBody>
       </p:sp>
     </p:spTree>
@@ -3458,7 +3388,7 @@
           <a:lstStyle/>
           <a:p>
             <a:r>
-              <a:t>Conclusion</a:t>
+              <a:t>* Definition:  Enabling computers to understand, interpret, and generate human language.</a:t>
             </a:r>
           </a:p>
         </p:txBody>
@@ -3477,11 +3407,343 @@
         <p:txBody>
           <a:bodyPr/>
           <a:lstStyle/>
-          <a:p>
-            <a:r>
-              <a:t>NLP is a rapidly evolving field with enormous potential. By addressing challenges and ethical considerations, we can create innovative and beneficial applications. Thank you.</a:t>
-            </a:r>
-          </a:p>
+          <a:p/>
+        </p:txBody>
+      </p:sp>
+    </p:spTree>
+  </p:cSld>
+  <p:clrMapOvr>
+    <a:masterClrMapping/>
+  </p:clrMapOvr>
+</p:sld>
+</file>
+
+<file path=ppt/slides/slide14.xml><?xml version="1.0" encoding="utf-8"?>
+<p:sld xmlns:a="http://schemas.openxmlformats.org/drawingml/2006/main" xmlns:p="http://schemas.openxmlformats.org/presentationml/2006/main" xmlns:r="http://schemas.openxmlformats.org/officeDocument/2006/relationships">
+  <p:cSld>
+    <p:spTree>
+      <p:nvGrpSpPr>
+        <p:cNvPr id="1" name=""/>
+        <p:cNvGrpSpPr/>
+        <p:nvPr/>
+      </p:nvGrpSpPr>
+      <p:grpSpPr/>
+      <p:sp>
+        <p:nvSpPr>
+          <p:cNvPr id="2" name="Title 1"/>
+          <p:cNvSpPr>
+            <a:spLocks noGrp="1"/>
+          </p:cNvSpPr>
+          <p:nvPr>
+            <p:ph type="title"/>
+          </p:nvPr>
+        </p:nvSpPr>
+        <p:spPr/>
+        <p:txBody>
+          <a:bodyPr/>
+          <a:lstStyle/>
+          <a:p>
+            <a:r>
+              <a:t>* Importance: Bridging the gap between human communication and machine understanding.</a:t>
+            </a:r>
+          </a:p>
+        </p:txBody>
+      </p:sp>
+      <p:sp>
+        <p:nvSpPr>
+          <p:cNvPr id="3" name="Content Placeholder 2"/>
+          <p:cNvSpPr>
+            <a:spLocks noGrp="1"/>
+          </p:cNvSpPr>
+          <p:nvPr>
+            <p:ph idx="1"/>
+          </p:nvPr>
+        </p:nvSpPr>
+        <p:spPr/>
+        <p:txBody>
+          <a:bodyPr/>
+          <a:lstStyle/>
+          <a:p/>
+        </p:txBody>
+      </p:sp>
+    </p:spTree>
+  </p:cSld>
+  <p:clrMapOvr>
+    <a:masterClrMapping/>
+  </p:clrMapOvr>
+</p:sld>
+</file>
+
+<file path=ppt/slides/slide15.xml><?xml version="1.0" encoding="utf-8"?>
+<p:sld xmlns:a="http://schemas.openxmlformats.org/drawingml/2006/main" xmlns:p="http://schemas.openxmlformats.org/presentationml/2006/main" xmlns:r="http://schemas.openxmlformats.org/officeDocument/2006/relationships">
+  <p:cSld>
+    <p:spTree>
+      <p:nvGrpSpPr>
+        <p:cNvPr id="1" name=""/>
+        <p:cNvGrpSpPr/>
+        <p:nvPr/>
+      </p:nvGrpSpPr>
+      <p:grpSpPr/>
+      <p:sp>
+        <p:nvSpPr>
+          <p:cNvPr id="2" name="Title 1"/>
+          <p:cNvSpPr>
+            <a:spLocks noGrp="1"/>
+          </p:cNvSpPr>
+          <p:nvPr>
+            <p:ph type="title"/>
+          </p:nvPr>
+        </p:nvSpPr>
+        <p:spPr/>
+        <p:txBody>
+          <a:bodyPr/>
+          <a:lstStyle/>
+          <a:p>
+            <a:r>
+              <a:t>* Real-world Applications: (Visual: show icons representing applications like chatbots, machine translation, sentiment analysis, speech recognition)  Chatbots, Machine Translation, Sentiment Analysis, Text Summarization, Speech Recognition, etc.</a:t>
+            </a:r>
+          </a:p>
+        </p:txBody>
+      </p:sp>
+      <p:sp>
+        <p:nvSpPr>
+          <p:cNvPr id="3" name="Content Placeholder 2"/>
+          <p:cNvSpPr>
+            <a:spLocks noGrp="1"/>
+          </p:cNvSpPr>
+          <p:nvPr>
+            <p:ph idx="1"/>
+          </p:nvPr>
+        </p:nvSpPr>
+        <p:spPr/>
+        <p:txBody>
+          <a:bodyPr/>
+          <a:lstStyle/>
+          <a:p/>
+        </p:txBody>
+      </p:sp>
+    </p:spTree>
+  </p:cSld>
+  <p:clrMapOvr>
+    <a:masterClrMapping/>
+  </p:clrMapOvr>
+</p:sld>
+</file>
+
+<file path=ppt/slides/slide16.xml><?xml version="1.0" encoding="utf-8"?>
+<p:sld xmlns:a="http://schemas.openxmlformats.org/drawingml/2006/main" xmlns:p="http://schemas.openxmlformats.org/presentationml/2006/main" xmlns:r="http://schemas.openxmlformats.org/officeDocument/2006/relationships">
+  <p:cSld>
+    <p:spTree>
+      <p:nvGrpSpPr>
+        <p:cNvPr id="1" name=""/>
+        <p:cNvGrpSpPr/>
+        <p:nvPr/>
+      </p:nvGrpSpPr>
+      <p:grpSpPr/>
+      <p:sp>
+        <p:nvSpPr>
+          <p:cNvPr id="2" name="Title 1"/>
+          <p:cNvSpPr>
+            <a:spLocks noGrp="1"/>
+          </p:cNvSpPr>
+          <p:nvPr>
+            <p:ph type="title"/>
+          </p:nvPr>
+        </p:nvSpPr>
+        <p:spPr/>
+        <p:txBody>
+          <a:bodyPr/>
+          <a:lstStyle/>
+          <a:p>
+            <a:r>
+              <a:t>**(Speaker Notes):**  At its core, NLP aims to make computers understand and use human language. This isn't just about recognizing words; it's about comprehending the meaning, context, and intent behind them. This has led to a myriad of applications, from the chatbots assisting you online to the sophisticated machine translation systems we use daily.  Think about how often you interact with technology using natural language – it's becoming increasingly pervasive. (Transition to next slide,  possibly with a smooth animation showing the evolution of NLP applications)</a:t>
+            </a:r>
+          </a:p>
+        </p:txBody>
+      </p:sp>
+      <p:sp>
+        <p:nvSpPr>
+          <p:cNvPr id="3" name="Content Placeholder 2"/>
+          <p:cNvSpPr>
+            <a:spLocks noGrp="1"/>
+          </p:cNvSpPr>
+          <p:nvPr>
+            <p:ph idx="1"/>
+          </p:nvPr>
+        </p:nvSpPr>
+        <p:spPr/>
+        <p:txBody>
+          <a:bodyPr/>
+          <a:lstStyle/>
+          <a:p/>
+        </p:txBody>
+      </p:sp>
+    </p:spTree>
+  </p:cSld>
+  <p:clrMapOvr>
+    <a:masterClrMapping/>
+  </p:clrMapOvr>
+</p:sld>
+</file>
+
+<file path=ppt/slides/slide17.xml><?xml version="1.0" encoding="utf-8"?>
+<p:sld xmlns:a="http://schemas.openxmlformats.org/drawingml/2006/main" xmlns:p="http://schemas.openxmlformats.org/presentationml/2006/main" xmlns:r="http://schemas.openxmlformats.org/officeDocument/2006/relationships">
+  <p:cSld>
+    <p:spTree>
+      <p:nvGrpSpPr>
+        <p:cNvPr id="1" name=""/>
+        <p:cNvGrpSpPr/>
+        <p:nvPr/>
+      </p:nvGrpSpPr>
+      <p:grpSpPr/>
+      <p:sp>
+        <p:nvSpPr>
+          <p:cNvPr id="2" name="Title 1"/>
+          <p:cNvSpPr>
+            <a:spLocks noGrp="1"/>
+          </p:cNvSpPr>
+          <p:nvPr>
+            <p:ph type="title"/>
+          </p:nvPr>
+        </p:nvSpPr>
+        <p:spPr/>
+        <p:txBody>
+          <a:bodyPr/>
+          <a:lstStyle/>
+          <a:p>
+            <a:r>
+              <a:t>**Slide 3: How NLP Works: Core Components (7 minutes)**</a:t>
+            </a:r>
+          </a:p>
+        </p:txBody>
+      </p:sp>
+      <p:sp>
+        <p:nvSpPr>
+          <p:cNvPr id="3" name="Content Placeholder 2"/>
+          <p:cNvSpPr>
+            <a:spLocks noGrp="1"/>
+          </p:cNvSpPr>
+          <p:nvPr>
+            <p:ph idx="1"/>
+          </p:nvPr>
+        </p:nvSpPr>
+        <p:spPr/>
+        <p:txBody>
+          <a:bodyPr/>
+          <a:lstStyle/>
+          <a:p/>
+        </p:txBody>
+      </p:sp>
+    </p:spTree>
+  </p:cSld>
+  <p:clrMapOvr>
+    <a:masterClrMapping/>
+  </p:clrMapOvr>
+</p:sld>
+</file>
+
+<file path=ppt/slides/slide18.xml><?xml version="1.0" encoding="utf-8"?>
+<p:sld xmlns:a="http://schemas.openxmlformats.org/drawingml/2006/main" xmlns:p="http://schemas.openxmlformats.org/presentationml/2006/main" xmlns:r="http://schemas.openxmlformats.org/officeDocument/2006/relationships">
+  <p:cSld>
+    <p:spTree>
+      <p:nvGrpSpPr>
+        <p:cNvPr id="1" name=""/>
+        <p:cNvGrpSpPr/>
+        <p:nvPr/>
+      </p:nvGrpSpPr>
+      <p:grpSpPr/>
+      <p:sp>
+        <p:nvSpPr>
+          <p:cNvPr id="2" name="Title 1"/>
+          <p:cNvSpPr>
+            <a:spLocks noGrp="1"/>
+          </p:cNvSpPr>
+          <p:nvPr>
+            <p:ph type="title"/>
+          </p:nvPr>
+        </p:nvSpPr>
+        <p:spPr/>
+        <p:txBody>
+          <a:bodyPr/>
+          <a:lstStyle/>
+          <a:p>
+            <a:r>
+              <a:t>* **Title:** Deconstructing Language: The Building Blocks of NLP</a:t>
+            </a:r>
+          </a:p>
+        </p:txBody>
+      </p:sp>
+      <p:sp>
+        <p:nvSpPr>
+          <p:cNvPr id="3" name="Content Placeholder 2"/>
+          <p:cNvSpPr>
+            <a:spLocks noGrp="1"/>
+          </p:cNvSpPr>
+          <p:nvPr>
+            <p:ph idx="1"/>
+          </p:nvPr>
+        </p:nvSpPr>
+        <p:spPr/>
+        <p:txBody>
+          <a:bodyPr/>
+          <a:lstStyle/>
+          <a:p/>
+        </p:txBody>
+      </p:sp>
+    </p:spTree>
+  </p:cSld>
+  <p:clrMapOvr>
+    <a:masterClrMapping/>
+  </p:clrMapOvr>
+</p:sld>
+</file>
+
+<file path=ppt/slides/slide19.xml><?xml version="1.0" encoding="utf-8"?>
+<p:sld xmlns:a="http://schemas.openxmlformats.org/drawingml/2006/main" xmlns:p="http://schemas.openxmlformats.org/presentationml/2006/main" xmlns:r="http://schemas.openxmlformats.org/officeDocument/2006/relationships">
+  <p:cSld>
+    <p:spTree>
+      <p:nvGrpSpPr>
+        <p:cNvPr id="1" name=""/>
+        <p:cNvGrpSpPr/>
+        <p:nvPr/>
+      </p:nvGrpSpPr>
+      <p:grpSpPr/>
+      <p:sp>
+        <p:nvSpPr>
+          <p:cNvPr id="2" name="Title 1"/>
+          <p:cNvSpPr>
+            <a:spLocks noGrp="1"/>
+          </p:cNvSpPr>
+          <p:nvPr>
+            <p:ph type="title"/>
+          </p:nvPr>
+        </p:nvSpPr>
+        <p:spPr/>
+        <p:txBody>
+          <a:bodyPr/>
+          <a:lstStyle/>
+          <a:p>
+            <a:r>
+              <a:t>* **Visual:** Flowchart illustrating the process:  Text Input -&gt; Tokenization -&gt; Parsing -&gt; Semantic Analysis -&gt; Output</a:t>
+            </a:r>
+          </a:p>
+        </p:txBody>
+      </p:sp>
+      <p:sp>
+        <p:nvSpPr>
+          <p:cNvPr id="3" name="Content Placeholder 2"/>
+          <p:cNvSpPr>
+            <a:spLocks noGrp="1"/>
+          </p:cNvSpPr>
+          <p:nvPr>
+            <p:ph idx="1"/>
+          </p:nvPr>
+        </p:nvSpPr>
+        <p:spPr/>
+        <p:txBody>
+          <a:bodyPr/>
+          <a:lstStyle/>
+          <a:p/>
         </p:txBody>
       </p:sp>
     </p:spTree>
@@ -3518,7 +3780,7 @@
           <a:lstStyle/>
           <a:p>
             <a:r>
-              <a:t>What is NLP?</a:t>
+              <a:t>## Natural Language Processing: Understanding and Shaping Human-Computer Interaction</a:t>
             </a:r>
           </a:p>
         </p:txBody>
@@ -3537,11 +3799,567 @@
         <p:txBody>
           <a:bodyPr/>
           <a:lstStyle/>
-          <a:p>
-            <a:r>
-              <a:t>NLP is a branch of AI that focuses on enabling computers to understand, interpret, and generate human language. It bridges the gap between human communication and computer understanding.</a:t>
-            </a:r>
-          </a:p>
+          <a:p/>
+        </p:txBody>
+      </p:sp>
+    </p:spTree>
+  </p:cSld>
+  <p:clrMapOvr>
+    <a:masterClrMapping/>
+  </p:clrMapOvr>
+</p:sld>
+</file>
+
+<file path=ppt/slides/slide20.xml><?xml version="1.0" encoding="utf-8"?>
+<p:sld xmlns:a="http://schemas.openxmlformats.org/drawingml/2006/main" xmlns:p="http://schemas.openxmlformats.org/presentationml/2006/main" xmlns:r="http://schemas.openxmlformats.org/officeDocument/2006/relationships">
+  <p:cSld>
+    <p:spTree>
+      <p:nvGrpSpPr>
+        <p:cNvPr id="1" name=""/>
+        <p:cNvGrpSpPr/>
+        <p:nvPr/>
+      </p:nvGrpSpPr>
+      <p:grpSpPr/>
+      <p:sp>
+        <p:nvSpPr>
+          <p:cNvPr id="2" name="Title 1"/>
+          <p:cNvSpPr>
+            <a:spLocks noGrp="1"/>
+          </p:cNvSpPr>
+          <p:nvPr>
+            <p:ph type="title"/>
+          </p:nvPr>
+        </p:nvSpPr>
+        <p:spPr/>
+        <p:txBody>
+          <a:bodyPr/>
+          <a:lstStyle/>
+          <a:p>
+            <a:r>
+              <a:t>* **Bullet Points:**</a:t>
+            </a:r>
+          </a:p>
+        </p:txBody>
+      </p:sp>
+      <p:sp>
+        <p:nvSpPr>
+          <p:cNvPr id="3" name="Content Placeholder 2"/>
+          <p:cNvSpPr>
+            <a:spLocks noGrp="1"/>
+          </p:cNvSpPr>
+          <p:nvPr>
+            <p:ph idx="1"/>
+          </p:nvPr>
+        </p:nvSpPr>
+        <p:spPr/>
+        <p:txBody>
+          <a:bodyPr/>
+          <a:lstStyle/>
+          <a:p/>
+        </p:txBody>
+      </p:sp>
+    </p:spTree>
+  </p:cSld>
+  <p:clrMapOvr>
+    <a:masterClrMapping/>
+  </p:clrMapOvr>
+</p:sld>
+</file>
+
+<file path=ppt/slides/slide21.xml><?xml version="1.0" encoding="utf-8"?>
+<p:sld xmlns:a="http://schemas.openxmlformats.org/drawingml/2006/main" xmlns:p="http://schemas.openxmlformats.org/presentationml/2006/main" xmlns:r="http://schemas.openxmlformats.org/officeDocument/2006/relationships">
+  <p:cSld>
+    <p:spTree>
+      <p:nvGrpSpPr>
+        <p:cNvPr id="1" name=""/>
+        <p:cNvGrpSpPr/>
+        <p:nvPr/>
+      </p:nvGrpSpPr>
+      <p:grpSpPr/>
+      <p:sp>
+        <p:nvSpPr>
+          <p:cNvPr id="2" name="Title 1"/>
+          <p:cNvSpPr>
+            <a:spLocks noGrp="1"/>
+          </p:cNvSpPr>
+          <p:nvPr>
+            <p:ph type="title"/>
+          </p:nvPr>
+        </p:nvSpPr>
+        <p:spPr/>
+        <p:txBody>
+          <a:bodyPr/>
+          <a:lstStyle/>
+          <a:p>
+            <a:r>
+              <a:t>* Tokenization: Breaking down text into individual words or phrases (tokens).</a:t>
+            </a:r>
+          </a:p>
+        </p:txBody>
+      </p:sp>
+      <p:sp>
+        <p:nvSpPr>
+          <p:cNvPr id="3" name="Content Placeholder 2"/>
+          <p:cNvSpPr>
+            <a:spLocks noGrp="1"/>
+          </p:cNvSpPr>
+          <p:nvPr>
+            <p:ph idx="1"/>
+          </p:nvPr>
+        </p:nvSpPr>
+        <p:spPr/>
+        <p:txBody>
+          <a:bodyPr/>
+          <a:lstStyle/>
+          <a:p/>
+        </p:txBody>
+      </p:sp>
+    </p:spTree>
+  </p:cSld>
+  <p:clrMapOvr>
+    <a:masterClrMapping/>
+  </p:clrMapOvr>
+</p:sld>
+</file>
+
+<file path=ppt/slides/slide22.xml><?xml version="1.0" encoding="utf-8"?>
+<p:sld xmlns:a="http://schemas.openxmlformats.org/drawingml/2006/main" xmlns:p="http://schemas.openxmlformats.org/presentationml/2006/main" xmlns:r="http://schemas.openxmlformats.org/officeDocument/2006/relationships">
+  <p:cSld>
+    <p:spTree>
+      <p:nvGrpSpPr>
+        <p:cNvPr id="1" name=""/>
+        <p:cNvGrpSpPr/>
+        <p:nvPr/>
+      </p:nvGrpSpPr>
+      <p:grpSpPr/>
+      <p:sp>
+        <p:nvSpPr>
+          <p:cNvPr id="2" name="Title 1"/>
+          <p:cNvSpPr>
+            <a:spLocks noGrp="1"/>
+          </p:cNvSpPr>
+          <p:nvPr>
+            <p:ph type="title"/>
+          </p:nvPr>
+        </p:nvSpPr>
+        <p:spPr/>
+        <p:txBody>
+          <a:bodyPr/>
+          <a:lstStyle/>
+          <a:p>
+            <a:r>
+              <a:t>* Parsing: Analyzing sentence structure to identify grammatical relationships.</a:t>
+            </a:r>
+          </a:p>
+        </p:txBody>
+      </p:sp>
+      <p:sp>
+        <p:nvSpPr>
+          <p:cNvPr id="3" name="Content Placeholder 2"/>
+          <p:cNvSpPr>
+            <a:spLocks noGrp="1"/>
+          </p:cNvSpPr>
+          <p:nvPr>
+            <p:ph idx="1"/>
+          </p:nvPr>
+        </p:nvSpPr>
+        <p:spPr/>
+        <p:txBody>
+          <a:bodyPr/>
+          <a:lstStyle/>
+          <a:p/>
+        </p:txBody>
+      </p:sp>
+    </p:spTree>
+  </p:cSld>
+  <p:clrMapOvr>
+    <a:masterClrMapping/>
+  </p:clrMapOvr>
+</p:sld>
+</file>
+
+<file path=ppt/slides/slide23.xml><?xml version="1.0" encoding="utf-8"?>
+<p:sld xmlns:a="http://schemas.openxmlformats.org/drawingml/2006/main" xmlns:p="http://schemas.openxmlformats.org/presentationml/2006/main" xmlns:r="http://schemas.openxmlformats.org/officeDocument/2006/relationships">
+  <p:cSld>
+    <p:spTree>
+      <p:nvGrpSpPr>
+        <p:cNvPr id="1" name=""/>
+        <p:cNvGrpSpPr/>
+        <p:nvPr/>
+      </p:nvGrpSpPr>
+      <p:grpSpPr/>
+      <p:sp>
+        <p:nvSpPr>
+          <p:cNvPr id="2" name="Title 1"/>
+          <p:cNvSpPr>
+            <a:spLocks noGrp="1"/>
+          </p:cNvSpPr>
+          <p:nvPr>
+            <p:ph type="title"/>
+          </p:nvPr>
+        </p:nvSpPr>
+        <p:spPr/>
+        <p:txBody>
+          <a:bodyPr/>
+          <a:lstStyle/>
+          <a:p>
+            <a:r>
+              <a:t>* Semantic Analysis: Understanding the meaning and context of words and sentences. (Explain the difference between syntax and semantics)</a:t>
+            </a:r>
+          </a:p>
+        </p:txBody>
+      </p:sp>
+      <p:sp>
+        <p:nvSpPr>
+          <p:cNvPr id="3" name="Content Placeholder 2"/>
+          <p:cNvSpPr>
+            <a:spLocks noGrp="1"/>
+          </p:cNvSpPr>
+          <p:nvPr>
+            <p:ph idx="1"/>
+          </p:nvPr>
+        </p:nvSpPr>
+        <p:spPr/>
+        <p:txBody>
+          <a:bodyPr/>
+          <a:lstStyle/>
+          <a:p/>
+        </p:txBody>
+      </p:sp>
+    </p:spTree>
+  </p:cSld>
+  <p:clrMapOvr>
+    <a:masterClrMapping/>
+  </p:clrMapOvr>
+</p:sld>
+</file>
+
+<file path=ppt/slides/slide24.xml><?xml version="1.0" encoding="utf-8"?>
+<p:sld xmlns:a="http://schemas.openxmlformats.org/drawingml/2006/main" xmlns:p="http://schemas.openxmlformats.org/presentationml/2006/main" xmlns:r="http://schemas.openxmlformats.org/officeDocument/2006/relationships">
+  <p:cSld>
+    <p:spTree>
+      <p:nvGrpSpPr>
+        <p:cNvPr id="1" name=""/>
+        <p:cNvGrpSpPr/>
+        <p:nvPr/>
+      </p:nvGrpSpPr>
+      <p:grpSpPr/>
+      <p:sp>
+        <p:nvSpPr>
+          <p:cNvPr id="2" name="Title 1"/>
+          <p:cNvSpPr>
+            <a:spLocks noGrp="1"/>
+          </p:cNvSpPr>
+          <p:nvPr>
+            <p:ph type="title"/>
+          </p:nvPr>
+        </p:nvSpPr>
+        <p:spPr/>
+        <p:txBody>
+          <a:bodyPr/>
+          <a:lstStyle/>
+          <a:p>
+            <a:r>
+              <a:t>**(Speaker Notes):** To understand how NLP works, imagine teaching a computer to read.  First, we need to break down the text into smaller units, a process called tokenization. Then, we need to understand the grammatical structure, which is parsing.  Finally, and most importantly, we need to grasp the actual meaning – this is semantic analysis. These are crucial steps towards making sense of human language. (Point to each part of the flowchart as you explain it).</a:t>
+            </a:r>
+          </a:p>
+        </p:txBody>
+      </p:sp>
+      <p:sp>
+        <p:nvSpPr>
+          <p:cNvPr id="3" name="Content Placeholder 2"/>
+          <p:cNvSpPr>
+            <a:spLocks noGrp="1"/>
+          </p:cNvSpPr>
+          <p:nvPr>
+            <p:ph idx="1"/>
+          </p:nvPr>
+        </p:nvSpPr>
+        <p:spPr/>
+        <p:txBody>
+          <a:bodyPr/>
+          <a:lstStyle/>
+          <a:p/>
+        </p:txBody>
+      </p:sp>
+    </p:spTree>
+  </p:cSld>
+  <p:clrMapOvr>
+    <a:masterClrMapping/>
+  </p:clrMapOvr>
+</p:sld>
+</file>
+
+<file path=ppt/slides/slide25.xml><?xml version="1.0" encoding="utf-8"?>
+<p:sld xmlns:a="http://schemas.openxmlformats.org/drawingml/2006/main" xmlns:p="http://schemas.openxmlformats.org/presentationml/2006/main" xmlns:r="http://schemas.openxmlformats.org/officeDocument/2006/relationships">
+  <p:cSld>
+    <p:spTree>
+      <p:nvGrpSpPr>
+        <p:cNvPr id="1" name=""/>
+        <p:cNvGrpSpPr/>
+        <p:nvPr/>
+      </p:nvGrpSpPr>
+      <p:grpSpPr/>
+      <p:sp>
+        <p:nvSpPr>
+          <p:cNvPr id="2" name="Title 1"/>
+          <p:cNvSpPr>
+            <a:spLocks noGrp="1"/>
+          </p:cNvSpPr>
+          <p:nvPr>
+            <p:ph type="title"/>
+          </p:nvPr>
+        </p:nvSpPr>
+        <p:spPr/>
+        <p:txBody>
+          <a:bodyPr/>
+          <a:lstStyle/>
+          <a:p>
+            <a:r>
+              <a:t>**Slide 4: Core Techniques (10 minutes)**</a:t>
+            </a:r>
+          </a:p>
+        </p:txBody>
+      </p:sp>
+      <p:sp>
+        <p:nvSpPr>
+          <p:cNvPr id="3" name="Content Placeholder 2"/>
+          <p:cNvSpPr>
+            <a:spLocks noGrp="1"/>
+          </p:cNvSpPr>
+          <p:nvPr>
+            <p:ph idx="1"/>
+          </p:nvPr>
+        </p:nvSpPr>
+        <p:spPr/>
+        <p:txBody>
+          <a:bodyPr/>
+          <a:lstStyle/>
+          <a:p/>
+        </p:txBody>
+      </p:sp>
+    </p:spTree>
+  </p:cSld>
+  <p:clrMapOvr>
+    <a:masterClrMapping/>
+  </p:clrMapOvr>
+</p:sld>
+</file>
+
+<file path=ppt/slides/slide26.xml><?xml version="1.0" encoding="utf-8"?>
+<p:sld xmlns:a="http://schemas.openxmlformats.org/drawingml/2006/main" xmlns:p="http://schemas.openxmlformats.org/presentationml/2006/main" xmlns:r="http://schemas.openxmlformats.org/officeDocument/2006/relationships">
+  <p:cSld>
+    <p:spTree>
+      <p:nvGrpSpPr>
+        <p:cNvPr id="1" name=""/>
+        <p:cNvGrpSpPr/>
+        <p:nvPr/>
+      </p:nvGrpSpPr>
+      <p:grpSpPr/>
+      <p:sp>
+        <p:nvSpPr>
+          <p:cNvPr id="2" name="Title 1"/>
+          <p:cNvSpPr>
+            <a:spLocks noGrp="1"/>
+          </p:cNvSpPr>
+          <p:nvPr>
+            <p:ph type="title"/>
+          </p:nvPr>
+        </p:nvSpPr>
+        <p:spPr/>
+        <p:txBody>
+          <a:bodyPr/>
+          <a:lstStyle/>
+          <a:p>
+            <a:r>
+              <a:t>* **Title:** The Power of Algorithms: Machine Learning and Deep Learning in NLP</a:t>
+            </a:r>
+          </a:p>
+        </p:txBody>
+      </p:sp>
+      <p:sp>
+        <p:nvSpPr>
+          <p:cNvPr id="3" name="Content Placeholder 2"/>
+          <p:cNvSpPr>
+            <a:spLocks noGrp="1"/>
+          </p:cNvSpPr>
+          <p:nvPr>
+            <p:ph idx="1"/>
+          </p:nvPr>
+        </p:nvSpPr>
+        <p:spPr/>
+        <p:txBody>
+          <a:bodyPr/>
+          <a:lstStyle/>
+          <a:p/>
+        </p:txBody>
+      </p:sp>
+    </p:spTree>
+  </p:cSld>
+  <p:clrMapOvr>
+    <a:masterClrMapping/>
+  </p:clrMapOvr>
+</p:sld>
+</file>
+
+<file path=ppt/slides/slide27.xml><?xml version="1.0" encoding="utf-8"?>
+<p:sld xmlns:a="http://schemas.openxmlformats.org/drawingml/2006/main" xmlns:p="http://schemas.openxmlformats.org/presentationml/2006/main" xmlns:r="http://schemas.openxmlformats.org/officeDocument/2006/relationships">
+  <p:cSld>
+    <p:spTree>
+      <p:nvGrpSpPr>
+        <p:cNvPr id="1" name=""/>
+        <p:cNvGrpSpPr/>
+        <p:nvPr/>
+      </p:nvGrpSpPr>
+      <p:grpSpPr/>
+      <p:sp>
+        <p:nvSpPr>
+          <p:cNvPr id="2" name="Title 1"/>
+          <p:cNvSpPr>
+            <a:spLocks noGrp="1"/>
+          </p:cNvSpPr>
+          <p:nvPr>
+            <p:ph type="title"/>
+          </p:nvPr>
+        </p:nvSpPr>
+        <p:spPr/>
+        <p:txBody>
+          <a:bodyPr/>
+          <a:lstStyle/>
+          <a:p>
+            <a:r>
+              <a:t>* **Bullet Points:**</a:t>
+            </a:r>
+          </a:p>
+        </p:txBody>
+      </p:sp>
+      <p:sp>
+        <p:nvSpPr>
+          <p:cNvPr id="3" name="Content Placeholder 2"/>
+          <p:cNvSpPr>
+            <a:spLocks noGrp="1"/>
+          </p:cNvSpPr>
+          <p:nvPr>
+            <p:ph idx="1"/>
+          </p:nvPr>
+        </p:nvSpPr>
+        <p:spPr/>
+        <p:txBody>
+          <a:bodyPr/>
+          <a:lstStyle/>
+          <a:p/>
+        </p:txBody>
+      </p:sp>
+    </p:spTree>
+  </p:cSld>
+  <p:clrMapOvr>
+    <a:masterClrMapping/>
+  </p:clrMapOvr>
+</p:sld>
+</file>
+
+<file path=ppt/slides/slide28.xml><?xml version="1.0" encoding="utf-8"?>
+<p:sld xmlns:a="http://schemas.openxmlformats.org/drawingml/2006/main" xmlns:p="http://schemas.openxmlformats.org/presentationml/2006/main" xmlns:r="http://schemas.openxmlformats.org/officeDocument/2006/relationships">
+  <p:cSld>
+    <p:spTree>
+      <p:nvGrpSpPr>
+        <p:cNvPr id="1" name=""/>
+        <p:cNvGrpSpPr/>
+        <p:nvPr/>
+      </p:nvGrpSpPr>
+      <p:grpSpPr/>
+      <p:sp>
+        <p:nvSpPr>
+          <p:cNvPr id="2" name="Title 1"/>
+          <p:cNvSpPr>
+            <a:spLocks noGrp="1"/>
+          </p:cNvSpPr>
+          <p:nvPr>
+            <p:ph type="title"/>
+          </p:nvPr>
+        </p:nvSpPr>
+        <p:spPr/>
+        <p:txBody>
+          <a:bodyPr/>
+          <a:lstStyle/>
+          <a:p>
+            <a:r>
+              <a:t>* Machine Learning (ML): Traditional methods like Naive Bayes, Support Vector Machines (SVMs), used for tasks like sentiment analysis, text classification.</a:t>
+            </a:r>
+          </a:p>
+        </p:txBody>
+      </p:sp>
+      <p:sp>
+        <p:nvSpPr>
+          <p:cNvPr id="3" name="Content Placeholder 2"/>
+          <p:cNvSpPr>
+            <a:spLocks noGrp="1"/>
+          </p:cNvSpPr>
+          <p:nvPr>
+            <p:ph idx="1"/>
+          </p:nvPr>
+        </p:nvSpPr>
+        <p:spPr/>
+        <p:txBody>
+          <a:bodyPr/>
+          <a:lstStyle/>
+          <a:p/>
+        </p:txBody>
+      </p:sp>
+    </p:spTree>
+  </p:cSld>
+  <p:clrMapOvr>
+    <a:masterClrMapping/>
+  </p:clrMapOvr>
+</p:sld>
+</file>
+
+<file path=ppt/slides/slide29.xml><?xml version="1.0" encoding="utf-8"?>
+<p:sld xmlns:a="http://schemas.openxmlformats.org/drawingml/2006/main" xmlns:p="http://schemas.openxmlformats.org/presentationml/2006/main" xmlns:r="http://schemas.openxmlformats.org/officeDocument/2006/relationships">
+  <p:cSld>
+    <p:spTree>
+      <p:nvGrpSpPr>
+        <p:cNvPr id="1" name=""/>
+        <p:cNvGrpSpPr/>
+        <p:nvPr/>
+      </p:nvGrpSpPr>
+      <p:grpSpPr/>
+      <p:sp>
+        <p:nvSpPr>
+          <p:cNvPr id="2" name="Title 1"/>
+          <p:cNvSpPr>
+            <a:spLocks noGrp="1"/>
+          </p:cNvSpPr>
+          <p:nvPr>
+            <p:ph type="title"/>
+          </p:nvPr>
+        </p:nvSpPr>
+        <p:spPr/>
+        <p:txBody>
+          <a:bodyPr/>
+          <a:lstStyle/>
+          <a:p>
+            <a:r>
+              <a:t>* Deep Learning (DL): Neural networks, particularly Recurrent Neural Networks (RNNs) and Long Short-Term Memory (LSTMs) for sequential data like text.  Introduce the concept of word embeddings (Word2Vec, GloVe).</a:t>
+            </a:r>
+          </a:p>
+        </p:txBody>
+      </p:sp>
+      <p:sp>
+        <p:nvSpPr>
+          <p:cNvPr id="3" name="Content Placeholder 2"/>
+          <p:cNvSpPr>
+            <a:spLocks noGrp="1"/>
+          </p:cNvSpPr>
+          <p:nvPr>
+            <p:ph idx="1"/>
+          </p:nvPr>
+        </p:nvSpPr>
+        <p:spPr/>
+        <p:txBody>
+          <a:bodyPr/>
+          <a:lstStyle/>
+          <a:p/>
         </p:txBody>
       </p:sp>
     </p:spTree>
@@ -3578,7 +4396,7 @@
           <a:lstStyle/>
           <a:p>
             <a:r>
-              <a:t>Challenges in NLP</a:t>
+              <a:t>**(Total Time: ~60 minutes)**</a:t>
             </a:r>
           </a:p>
         </p:txBody>
@@ -3598,38 +4416,566 @@
           <a:bodyPr/>
           <a:lstStyle/>
           <a:p/>
-          <a:p>
-            <a:pPr>
-              <a:defRPr sz="1800"/>
-            </a:pPr>
-            <a:r>
-              <a:t>Ambiguity: Words and sentences can have multiple meanings.</a:t>
-            </a:r>
-          </a:p>
-          <a:p>
-            <a:pPr>
-              <a:defRPr sz="1800"/>
-            </a:pPr>
-            <a:r>
-              <a:t>Context Dependence: Meaning is influenced by surrounding words and context.</a:t>
-            </a:r>
-          </a:p>
-          <a:p>
-            <a:pPr>
-              <a:defRPr sz="1800"/>
-            </a:pPr>
-            <a:r>
-              <a:t>Variability: Language changes constantly.</a:t>
-            </a:r>
-          </a:p>
-          <a:p>
-            <a:pPr>
-              <a:defRPr sz="1800"/>
-            </a:pPr>
-            <a:r>
-              <a:t>Data Sparsity: High-quality datasets are scarce for some languages.</a:t>
-            </a:r>
-          </a:p>
+        </p:txBody>
+      </p:sp>
+    </p:spTree>
+  </p:cSld>
+  <p:clrMapOvr>
+    <a:masterClrMapping/>
+  </p:clrMapOvr>
+</p:sld>
+</file>
+
+<file path=ppt/slides/slide30.xml><?xml version="1.0" encoding="utf-8"?>
+<p:sld xmlns:a="http://schemas.openxmlformats.org/drawingml/2006/main" xmlns:p="http://schemas.openxmlformats.org/presentationml/2006/main" xmlns:r="http://schemas.openxmlformats.org/officeDocument/2006/relationships">
+  <p:cSld>
+    <p:spTree>
+      <p:nvGrpSpPr>
+        <p:cNvPr id="1" name=""/>
+        <p:cNvGrpSpPr/>
+        <p:nvPr/>
+      </p:nvGrpSpPr>
+      <p:grpSpPr/>
+      <p:sp>
+        <p:nvSpPr>
+          <p:cNvPr id="2" name="Title 1"/>
+          <p:cNvSpPr>
+            <a:spLocks noGrp="1"/>
+          </p:cNvSpPr>
+          <p:nvPr>
+            <p:ph type="title"/>
+          </p:nvPr>
+        </p:nvSpPr>
+        <p:spPr/>
+        <p:txBody>
+          <a:bodyPr/>
+          <a:lstStyle/>
+          <a:p>
+            <a:r>
+              <a:t>* Transformer Models: Attention mechanisms, significantly improved performance, examples: BERT, GPT-3. (Visual: simple diagram comparing RNN and Transformer architecture)</a:t>
+            </a:r>
+          </a:p>
+        </p:txBody>
+      </p:sp>
+      <p:sp>
+        <p:nvSpPr>
+          <p:cNvPr id="3" name="Content Placeholder 2"/>
+          <p:cNvSpPr>
+            <a:spLocks noGrp="1"/>
+          </p:cNvSpPr>
+          <p:nvPr>
+            <p:ph idx="1"/>
+          </p:nvPr>
+        </p:nvSpPr>
+        <p:spPr/>
+        <p:txBody>
+          <a:bodyPr/>
+          <a:lstStyle/>
+          <a:p/>
+        </p:txBody>
+      </p:sp>
+    </p:spTree>
+  </p:cSld>
+  <p:clrMapOvr>
+    <a:masterClrMapping/>
+  </p:clrMapOvr>
+</p:sld>
+</file>
+
+<file path=ppt/slides/slide31.xml><?xml version="1.0" encoding="utf-8"?>
+<p:sld xmlns:a="http://schemas.openxmlformats.org/drawingml/2006/main" xmlns:p="http://schemas.openxmlformats.org/presentationml/2006/main" xmlns:r="http://schemas.openxmlformats.org/officeDocument/2006/relationships">
+  <p:cSld>
+    <p:spTree>
+      <p:nvGrpSpPr>
+        <p:cNvPr id="1" name=""/>
+        <p:cNvGrpSpPr/>
+        <p:nvPr/>
+      </p:nvGrpSpPr>
+      <p:grpSpPr/>
+      <p:sp>
+        <p:nvSpPr>
+          <p:cNvPr id="2" name="Title 1"/>
+          <p:cNvSpPr>
+            <a:spLocks noGrp="1"/>
+          </p:cNvSpPr>
+          <p:nvPr>
+            <p:ph type="title"/>
+          </p:nvPr>
+        </p:nvSpPr>
+        <p:spPr/>
+        <p:txBody>
+          <a:bodyPr/>
+          <a:lstStyle/>
+          <a:p>
+            <a:r>
+              <a:t>**(Speaker Notes):**  The power of NLP comes from algorithms.  Traditionally, machine learning techniques were used, but deep learning has revolutionized the field. Deep learning models, particularly recurrent neural networks, excel at handling the sequential nature of language.  However, the recent breakthroughs have been driven by transformer models, which use attention mechanisms to process information more efficiently. These models are behind many of the advancements we see today, like the highly sophisticated language models that power chatbots and writing assistants. (Explain the key difference between RNN and Transformer, emphasizing attention mechanism)</a:t>
+            </a:r>
+          </a:p>
+        </p:txBody>
+      </p:sp>
+      <p:sp>
+        <p:nvSpPr>
+          <p:cNvPr id="3" name="Content Placeholder 2"/>
+          <p:cNvSpPr>
+            <a:spLocks noGrp="1"/>
+          </p:cNvSpPr>
+          <p:nvPr>
+            <p:ph idx="1"/>
+          </p:nvPr>
+        </p:nvSpPr>
+        <p:spPr/>
+        <p:txBody>
+          <a:bodyPr/>
+          <a:lstStyle/>
+          <a:p/>
+        </p:txBody>
+      </p:sp>
+    </p:spTree>
+  </p:cSld>
+  <p:clrMapOvr>
+    <a:masterClrMapping/>
+  </p:clrMapOvr>
+</p:sld>
+</file>
+
+<file path=ppt/slides/slide32.xml><?xml version="1.0" encoding="utf-8"?>
+<p:sld xmlns:a="http://schemas.openxmlformats.org/drawingml/2006/main" xmlns:p="http://schemas.openxmlformats.org/presentationml/2006/main" xmlns:r="http://schemas.openxmlformats.org/officeDocument/2006/relationships">
+  <p:cSld>
+    <p:spTree>
+      <p:nvGrpSpPr>
+        <p:cNvPr id="1" name=""/>
+        <p:cNvGrpSpPr/>
+        <p:nvPr/>
+      </p:nvGrpSpPr>
+      <p:grpSpPr/>
+      <p:sp>
+        <p:nvSpPr>
+          <p:cNvPr id="2" name="Title 1"/>
+          <p:cNvSpPr>
+            <a:spLocks noGrp="1"/>
+          </p:cNvSpPr>
+          <p:nvPr>
+            <p:ph type="title"/>
+          </p:nvPr>
+        </p:nvSpPr>
+        <p:spPr/>
+        <p:txBody>
+          <a:bodyPr/>
+          <a:lstStyle/>
+          <a:p>
+            <a:r>
+              <a:t>**Slide 5: Real-World Challenges (7 minutes)**</a:t>
+            </a:r>
+          </a:p>
+        </p:txBody>
+      </p:sp>
+      <p:sp>
+        <p:nvSpPr>
+          <p:cNvPr id="3" name="Content Placeholder 2"/>
+          <p:cNvSpPr>
+            <a:spLocks noGrp="1"/>
+          </p:cNvSpPr>
+          <p:nvPr>
+            <p:ph idx="1"/>
+          </p:nvPr>
+        </p:nvSpPr>
+        <p:spPr/>
+        <p:txBody>
+          <a:bodyPr/>
+          <a:lstStyle/>
+          <a:p/>
+        </p:txBody>
+      </p:sp>
+    </p:spTree>
+  </p:cSld>
+  <p:clrMapOvr>
+    <a:masterClrMapping/>
+  </p:clrMapOvr>
+</p:sld>
+</file>
+
+<file path=ppt/slides/slide33.xml><?xml version="1.0" encoding="utf-8"?>
+<p:sld xmlns:a="http://schemas.openxmlformats.org/drawingml/2006/main" xmlns:p="http://schemas.openxmlformats.org/presentationml/2006/main" xmlns:r="http://schemas.openxmlformats.org/officeDocument/2006/relationships">
+  <p:cSld>
+    <p:spTree>
+      <p:nvGrpSpPr>
+        <p:cNvPr id="1" name=""/>
+        <p:cNvGrpSpPr/>
+        <p:nvPr/>
+      </p:nvGrpSpPr>
+      <p:grpSpPr/>
+      <p:sp>
+        <p:nvSpPr>
+          <p:cNvPr id="2" name="Title 1"/>
+          <p:cNvSpPr>
+            <a:spLocks noGrp="1"/>
+          </p:cNvSpPr>
+          <p:nvPr>
+            <p:ph type="title"/>
+          </p:nvPr>
+        </p:nvSpPr>
+        <p:spPr/>
+        <p:txBody>
+          <a:bodyPr/>
+          <a:lstStyle/>
+          <a:p>
+            <a:r>
+              <a:t>* **Title:** Navigating the Complexities of Language</a:t>
+            </a:r>
+          </a:p>
+        </p:txBody>
+      </p:sp>
+      <p:sp>
+        <p:nvSpPr>
+          <p:cNvPr id="3" name="Content Placeholder 2"/>
+          <p:cNvSpPr>
+            <a:spLocks noGrp="1"/>
+          </p:cNvSpPr>
+          <p:nvPr>
+            <p:ph idx="1"/>
+          </p:nvPr>
+        </p:nvSpPr>
+        <p:spPr/>
+        <p:txBody>
+          <a:bodyPr/>
+          <a:lstStyle/>
+          <a:p/>
+        </p:txBody>
+      </p:sp>
+    </p:spTree>
+  </p:cSld>
+  <p:clrMapOvr>
+    <a:masterClrMapping/>
+  </p:clrMapOvr>
+</p:sld>
+</file>
+
+<file path=ppt/slides/slide34.xml><?xml version="1.0" encoding="utf-8"?>
+<p:sld xmlns:a="http://schemas.openxmlformats.org/drawingml/2006/main" xmlns:p="http://schemas.openxmlformats.org/presentationml/2006/main" xmlns:r="http://schemas.openxmlformats.org/officeDocument/2006/relationships">
+  <p:cSld>
+    <p:spTree>
+      <p:nvGrpSpPr>
+        <p:cNvPr id="1" name=""/>
+        <p:cNvGrpSpPr/>
+        <p:nvPr/>
+      </p:nvGrpSpPr>
+      <p:grpSpPr/>
+      <p:sp>
+        <p:nvSpPr>
+          <p:cNvPr id="2" name="Title 1"/>
+          <p:cNvSpPr>
+            <a:spLocks noGrp="1"/>
+          </p:cNvSpPr>
+          <p:nvPr>
+            <p:ph type="title"/>
+          </p:nvPr>
+        </p:nvSpPr>
+        <p:spPr/>
+        <p:txBody>
+          <a:bodyPr/>
+          <a:lstStyle/>
+          <a:p>
+            <a:r>
+              <a:t>* **Bullet Points:**</a:t>
+            </a:r>
+          </a:p>
+        </p:txBody>
+      </p:sp>
+      <p:sp>
+        <p:nvSpPr>
+          <p:cNvPr id="3" name="Content Placeholder 2"/>
+          <p:cNvSpPr>
+            <a:spLocks noGrp="1"/>
+          </p:cNvSpPr>
+          <p:nvPr>
+            <p:ph idx="1"/>
+          </p:nvPr>
+        </p:nvSpPr>
+        <p:spPr/>
+        <p:txBody>
+          <a:bodyPr/>
+          <a:lstStyle/>
+          <a:p/>
+        </p:txBody>
+      </p:sp>
+    </p:spTree>
+  </p:cSld>
+  <p:clrMapOvr>
+    <a:masterClrMapping/>
+  </p:clrMapOvr>
+</p:sld>
+</file>
+
+<file path=ppt/slides/slide35.xml><?xml version="1.0" encoding="utf-8"?>
+<p:sld xmlns:a="http://schemas.openxmlformats.org/drawingml/2006/main" xmlns:p="http://schemas.openxmlformats.org/presentationml/2006/main" xmlns:r="http://schemas.openxmlformats.org/officeDocument/2006/relationships">
+  <p:cSld>
+    <p:spTree>
+      <p:nvGrpSpPr>
+        <p:cNvPr id="1" name=""/>
+        <p:cNvGrpSpPr/>
+        <p:nvPr/>
+      </p:nvGrpSpPr>
+      <p:grpSpPr/>
+      <p:sp>
+        <p:nvSpPr>
+          <p:cNvPr id="2" name="Title 1"/>
+          <p:cNvSpPr>
+            <a:spLocks noGrp="1"/>
+          </p:cNvSpPr>
+          <p:nvPr>
+            <p:ph type="title"/>
+          </p:nvPr>
+        </p:nvSpPr>
+        <p:spPr/>
+        <p:txBody>
+          <a:bodyPr/>
+          <a:lstStyle/>
+          <a:p>
+            <a:r>
+              <a:t>* Ambiguity: Words and sentences can have multiple meanings depending on context.</a:t>
+            </a:r>
+          </a:p>
+        </p:txBody>
+      </p:sp>
+      <p:sp>
+        <p:nvSpPr>
+          <p:cNvPr id="3" name="Content Placeholder 2"/>
+          <p:cNvSpPr>
+            <a:spLocks noGrp="1"/>
+          </p:cNvSpPr>
+          <p:nvPr>
+            <p:ph idx="1"/>
+          </p:nvPr>
+        </p:nvSpPr>
+        <p:spPr/>
+        <p:txBody>
+          <a:bodyPr/>
+          <a:lstStyle/>
+          <a:p/>
+        </p:txBody>
+      </p:sp>
+    </p:spTree>
+  </p:cSld>
+  <p:clrMapOvr>
+    <a:masterClrMapping/>
+  </p:clrMapOvr>
+</p:sld>
+</file>
+
+<file path=ppt/slides/slide36.xml><?xml version="1.0" encoding="utf-8"?>
+<p:sld xmlns:a="http://schemas.openxmlformats.org/drawingml/2006/main" xmlns:p="http://schemas.openxmlformats.org/presentationml/2006/main" xmlns:r="http://schemas.openxmlformats.org/officeDocument/2006/relationships">
+  <p:cSld>
+    <p:spTree>
+      <p:nvGrpSpPr>
+        <p:cNvPr id="1" name=""/>
+        <p:cNvGrpSpPr/>
+        <p:nvPr/>
+      </p:nvGrpSpPr>
+      <p:grpSpPr/>
+      <p:sp>
+        <p:nvSpPr>
+          <p:cNvPr id="2" name="Title 1"/>
+          <p:cNvSpPr>
+            <a:spLocks noGrp="1"/>
+          </p:cNvSpPr>
+          <p:nvPr>
+            <p:ph type="title"/>
+          </p:nvPr>
+        </p:nvSpPr>
+        <p:spPr/>
+        <p:txBody>
+          <a:bodyPr/>
+          <a:lstStyle/>
+          <a:p>
+            <a:r>
+              <a:t>* Contextual Understanding: Meaning often depends on surrounding words and sentences.</a:t>
+            </a:r>
+          </a:p>
+        </p:txBody>
+      </p:sp>
+      <p:sp>
+        <p:nvSpPr>
+          <p:cNvPr id="3" name="Content Placeholder 2"/>
+          <p:cNvSpPr>
+            <a:spLocks noGrp="1"/>
+          </p:cNvSpPr>
+          <p:nvPr>
+            <p:ph idx="1"/>
+          </p:nvPr>
+        </p:nvSpPr>
+        <p:spPr/>
+        <p:txBody>
+          <a:bodyPr/>
+          <a:lstStyle/>
+          <a:p/>
+        </p:txBody>
+      </p:sp>
+    </p:spTree>
+  </p:cSld>
+  <p:clrMapOvr>
+    <a:masterClrMapping/>
+  </p:clrMapOvr>
+</p:sld>
+</file>
+
+<file path=ppt/slides/slide37.xml><?xml version="1.0" encoding="utf-8"?>
+<p:sld xmlns:a="http://schemas.openxmlformats.org/drawingml/2006/main" xmlns:p="http://schemas.openxmlformats.org/presentationml/2006/main" xmlns:r="http://schemas.openxmlformats.org/officeDocument/2006/relationships">
+  <p:cSld>
+    <p:spTree>
+      <p:nvGrpSpPr>
+        <p:cNvPr id="1" name=""/>
+        <p:cNvGrpSpPr/>
+        <p:nvPr/>
+      </p:nvGrpSpPr>
+      <p:grpSpPr/>
+      <p:sp>
+        <p:nvSpPr>
+          <p:cNvPr id="2" name="Title 1"/>
+          <p:cNvSpPr>
+            <a:spLocks noGrp="1"/>
+          </p:cNvSpPr>
+          <p:nvPr>
+            <p:ph type="title"/>
+          </p:nvPr>
+        </p:nvSpPr>
+        <p:spPr/>
+        <p:txBody>
+          <a:bodyPr/>
+          <a:lstStyle/>
+          <a:p>
+            <a:r>
+              <a:t>* Handling Large Datasets: Training complex models requires massive amounts of data. (Visual: Examples of ambiguous sentences and challenges related to context)</a:t>
+            </a:r>
+          </a:p>
+        </p:txBody>
+      </p:sp>
+      <p:sp>
+        <p:nvSpPr>
+          <p:cNvPr id="3" name="Content Placeholder 2"/>
+          <p:cNvSpPr>
+            <a:spLocks noGrp="1"/>
+          </p:cNvSpPr>
+          <p:nvPr>
+            <p:ph idx="1"/>
+          </p:nvPr>
+        </p:nvSpPr>
+        <p:spPr/>
+        <p:txBody>
+          <a:bodyPr/>
+          <a:lstStyle/>
+          <a:p/>
+        </p:txBody>
+      </p:sp>
+    </p:spTree>
+  </p:cSld>
+  <p:clrMapOvr>
+    <a:masterClrMapping/>
+  </p:clrMapOvr>
+</p:sld>
+</file>
+
+<file path=ppt/slides/slide38.xml><?xml version="1.0" encoding="utf-8"?>
+<p:sld xmlns:a="http://schemas.openxmlformats.org/drawingml/2006/main" xmlns:p="http://schemas.openxmlformats.org/presentationml/2006/main" xmlns:r="http://schemas.openxmlformats.org/officeDocument/2006/relationships">
+  <p:cSld>
+    <p:spTree>
+      <p:nvGrpSpPr>
+        <p:cNvPr id="1" name=""/>
+        <p:cNvGrpSpPr/>
+        <p:nvPr/>
+      </p:nvGrpSpPr>
+      <p:grpSpPr/>
+      <p:sp>
+        <p:nvSpPr>
+          <p:cNvPr id="2" name="Title 1"/>
+          <p:cNvSpPr>
+            <a:spLocks noGrp="1"/>
+          </p:cNvSpPr>
+          <p:nvPr>
+            <p:ph type="title"/>
+          </p:nvPr>
+        </p:nvSpPr>
+        <p:spPr/>
+        <p:txBody>
+          <a:bodyPr/>
+          <a:lstStyle/>
+          <a:p>
+            <a:r>
+              <a:t>**(Speaker Notes):**  Despite impressive advancements, NLP still faces significant challenges. Human language is inherently ambiguous. A single word can have multiple meanings, and understanding the intended meaning often requires understanding the context.  Furthermore, training these powerful models requires huge datasets, making data acquisition and curation a significant hurdle. (Show the example sentences, highlighting the ambiguity and contextual issues).</a:t>
+            </a:r>
+          </a:p>
+        </p:txBody>
+      </p:sp>
+      <p:sp>
+        <p:nvSpPr>
+          <p:cNvPr id="3" name="Content Placeholder 2"/>
+          <p:cNvSpPr>
+            <a:spLocks noGrp="1"/>
+          </p:cNvSpPr>
+          <p:nvPr>
+            <p:ph idx="1"/>
+          </p:nvPr>
+        </p:nvSpPr>
+        <p:spPr/>
+        <p:txBody>
+          <a:bodyPr/>
+          <a:lstStyle/>
+          <a:p/>
+        </p:txBody>
+      </p:sp>
+    </p:spTree>
+  </p:cSld>
+  <p:clrMapOvr>
+    <a:masterClrMapping/>
+  </p:clrMapOvr>
+</p:sld>
+</file>
+
+<file path=ppt/slides/slide39.xml><?xml version="1.0" encoding="utf-8"?>
+<p:sld xmlns:a="http://schemas.openxmlformats.org/drawingml/2006/main" xmlns:p="http://schemas.openxmlformats.org/presentationml/2006/main" xmlns:r="http://schemas.openxmlformats.org/officeDocument/2006/relationships">
+  <p:cSld>
+    <p:spTree>
+      <p:nvGrpSpPr>
+        <p:cNvPr id="1" name=""/>
+        <p:cNvGrpSpPr/>
+        <p:nvPr/>
+      </p:nvGrpSpPr>
+      <p:grpSpPr/>
+      <p:sp>
+        <p:nvSpPr>
+          <p:cNvPr id="2" name="Title 1"/>
+          <p:cNvSpPr>
+            <a:spLocks noGrp="1"/>
+          </p:cNvSpPr>
+          <p:nvPr>
+            <p:ph type="title"/>
+          </p:nvPr>
+        </p:nvSpPr>
+        <p:spPr/>
+        <p:txBody>
+          <a:bodyPr/>
+          <a:lstStyle/>
+          <a:p>
+            <a:r>
+              <a:t>**Slide 6: Future of NLP (10 minutes)**</a:t>
+            </a:r>
+          </a:p>
+        </p:txBody>
+      </p:sp>
+      <p:sp>
+        <p:nvSpPr>
+          <p:cNvPr id="3" name="Content Placeholder 2"/>
+          <p:cNvSpPr>
+            <a:spLocks noGrp="1"/>
+          </p:cNvSpPr>
+          <p:nvPr>
+            <p:ph idx="1"/>
+          </p:nvPr>
+        </p:nvSpPr>
+        <p:spPr/>
+        <p:txBody>
+          <a:bodyPr/>
+          <a:lstStyle/>
+          <a:p/>
         </p:txBody>
       </p:sp>
     </p:spTree>
@@ -3666,7 +5012,7 @@
           <a:lstStyle/>
           <a:p>
             <a:r>
-              <a:t>Key NLP Tasks</a:t>
+              <a:t>**Slide 1: Title Slide (2 minutes)**</a:t>
             </a:r>
           </a:p>
         </p:txBody>
@@ -3686,62 +5032,566 @@
           <a:bodyPr/>
           <a:lstStyle/>
           <a:p/>
-          <a:p>
-            <a:pPr>
-              <a:defRPr sz="1800"/>
-            </a:pPr>
-            <a:r>
-              <a:t>Text Classification: Sentiment analysis, spam detection.</a:t>
-            </a:r>
-          </a:p>
-          <a:p>
-            <a:pPr>
-              <a:defRPr sz="1800"/>
-            </a:pPr>
-            <a:r>
-              <a:t>Machine Translation: Converting text from one language to another.</a:t>
-            </a:r>
-          </a:p>
-          <a:p>
-            <a:pPr>
-              <a:defRPr sz="1800"/>
-            </a:pPr>
-            <a:r>
-              <a:t>Named Entity Recognition: Identifying people, places, organizations.</a:t>
-            </a:r>
-          </a:p>
-          <a:p>
-            <a:pPr>
-              <a:defRPr sz="1800"/>
-            </a:pPr>
-            <a:r>
-              <a:t>Part-of-Speech Tagging: Assigning grammatical tags to words.</a:t>
-            </a:r>
-          </a:p>
-          <a:p>
-            <a:pPr>
-              <a:defRPr sz="1800"/>
-            </a:pPr>
-            <a:r>
-              <a:t>Question Answering: Answering questions posed in natural language.</a:t>
-            </a:r>
-          </a:p>
-          <a:p>
-            <a:pPr>
-              <a:defRPr sz="1800"/>
-            </a:pPr>
-            <a:r>
-              <a:t>Text Summarization: Creating concise summaries of texts.</a:t>
-            </a:r>
-          </a:p>
-          <a:p>
-            <a:pPr>
-              <a:defRPr sz="1800"/>
-            </a:pPr>
-            <a:r>
-              <a:t>Dialogue Systems (Chatbots): Building systems that can engage in conversations.</a:t>
-            </a:r>
-          </a:p>
+        </p:txBody>
+      </p:sp>
+    </p:spTree>
+  </p:cSld>
+  <p:clrMapOvr>
+    <a:masterClrMapping/>
+  </p:clrMapOvr>
+</p:sld>
+</file>
+
+<file path=ppt/slides/slide40.xml><?xml version="1.0" encoding="utf-8"?>
+<p:sld xmlns:a="http://schemas.openxmlformats.org/drawingml/2006/main" xmlns:p="http://schemas.openxmlformats.org/presentationml/2006/main" xmlns:r="http://schemas.openxmlformats.org/officeDocument/2006/relationships">
+  <p:cSld>
+    <p:spTree>
+      <p:nvGrpSpPr>
+        <p:cNvPr id="1" name=""/>
+        <p:cNvGrpSpPr/>
+        <p:nvPr/>
+      </p:nvGrpSpPr>
+      <p:grpSpPr/>
+      <p:sp>
+        <p:nvSpPr>
+          <p:cNvPr id="2" name="Title 1"/>
+          <p:cNvSpPr>
+            <a:spLocks noGrp="1"/>
+          </p:cNvSpPr>
+          <p:nvPr>
+            <p:ph type="title"/>
+          </p:nvPr>
+        </p:nvSpPr>
+        <p:spPr/>
+        <p:txBody>
+          <a:bodyPr/>
+          <a:lstStyle/>
+          <a:p>
+            <a:r>
+              <a:t>* **Title:** The Evolving Landscape of NLP: Trends and Ethical Considerations</a:t>
+            </a:r>
+          </a:p>
+        </p:txBody>
+      </p:sp>
+      <p:sp>
+        <p:nvSpPr>
+          <p:cNvPr id="3" name="Content Placeholder 2"/>
+          <p:cNvSpPr>
+            <a:spLocks noGrp="1"/>
+          </p:cNvSpPr>
+          <p:nvPr>
+            <p:ph idx="1"/>
+          </p:nvPr>
+        </p:nvSpPr>
+        <p:spPr/>
+        <p:txBody>
+          <a:bodyPr/>
+          <a:lstStyle/>
+          <a:p/>
+        </p:txBody>
+      </p:sp>
+    </p:spTree>
+  </p:cSld>
+  <p:clrMapOvr>
+    <a:masterClrMapping/>
+  </p:clrMapOvr>
+</p:sld>
+</file>
+
+<file path=ppt/slides/slide41.xml><?xml version="1.0" encoding="utf-8"?>
+<p:sld xmlns:a="http://schemas.openxmlformats.org/drawingml/2006/main" xmlns:p="http://schemas.openxmlformats.org/presentationml/2006/main" xmlns:r="http://schemas.openxmlformats.org/officeDocument/2006/relationships">
+  <p:cSld>
+    <p:spTree>
+      <p:nvGrpSpPr>
+        <p:cNvPr id="1" name=""/>
+        <p:cNvGrpSpPr/>
+        <p:nvPr/>
+      </p:nvGrpSpPr>
+      <p:grpSpPr/>
+      <p:sp>
+        <p:nvSpPr>
+          <p:cNvPr id="2" name="Title 1"/>
+          <p:cNvSpPr>
+            <a:spLocks noGrp="1"/>
+          </p:cNvSpPr>
+          <p:nvPr>
+            <p:ph type="title"/>
+          </p:nvPr>
+        </p:nvSpPr>
+        <p:spPr/>
+        <p:txBody>
+          <a:bodyPr/>
+          <a:lstStyle/>
+          <a:p>
+            <a:r>
+              <a:t>* **Bullet Points:**</a:t>
+            </a:r>
+          </a:p>
+        </p:txBody>
+      </p:sp>
+      <p:sp>
+        <p:nvSpPr>
+          <p:cNvPr id="3" name="Content Placeholder 2"/>
+          <p:cNvSpPr>
+            <a:spLocks noGrp="1"/>
+          </p:cNvSpPr>
+          <p:nvPr>
+            <p:ph idx="1"/>
+          </p:nvPr>
+        </p:nvSpPr>
+        <p:spPr/>
+        <p:txBody>
+          <a:bodyPr/>
+          <a:lstStyle/>
+          <a:p/>
+        </p:txBody>
+      </p:sp>
+    </p:spTree>
+  </p:cSld>
+  <p:clrMapOvr>
+    <a:masterClrMapping/>
+  </p:clrMapOvr>
+</p:sld>
+</file>
+
+<file path=ppt/slides/slide42.xml><?xml version="1.0" encoding="utf-8"?>
+<p:sld xmlns:a="http://schemas.openxmlformats.org/drawingml/2006/main" xmlns:p="http://schemas.openxmlformats.org/presentationml/2006/main" xmlns:r="http://schemas.openxmlformats.org/officeDocument/2006/relationships">
+  <p:cSld>
+    <p:spTree>
+      <p:nvGrpSpPr>
+        <p:cNvPr id="1" name=""/>
+        <p:cNvGrpSpPr/>
+        <p:nvPr/>
+      </p:nvGrpSpPr>
+      <p:grpSpPr/>
+      <p:sp>
+        <p:nvSpPr>
+          <p:cNvPr id="2" name="Title 1"/>
+          <p:cNvSpPr>
+            <a:spLocks noGrp="1"/>
+          </p:cNvSpPr>
+          <p:nvPr>
+            <p:ph type="title"/>
+          </p:nvPr>
+        </p:nvSpPr>
+        <p:spPr/>
+        <p:txBody>
+          <a:bodyPr/>
+          <a:lstStyle/>
+          <a:p>
+            <a:r>
+              <a:t>* Multilingual Models: Processing and translating multiple languages simultaneously.</a:t>
+            </a:r>
+          </a:p>
+        </p:txBody>
+      </p:sp>
+      <p:sp>
+        <p:nvSpPr>
+          <p:cNvPr id="3" name="Content Placeholder 2"/>
+          <p:cNvSpPr>
+            <a:spLocks noGrp="1"/>
+          </p:cNvSpPr>
+          <p:nvPr>
+            <p:ph idx="1"/>
+          </p:nvPr>
+        </p:nvSpPr>
+        <p:spPr/>
+        <p:txBody>
+          <a:bodyPr/>
+          <a:lstStyle/>
+          <a:p/>
+        </p:txBody>
+      </p:sp>
+    </p:spTree>
+  </p:cSld>
+  <p:clrMapOvr>
+    <a:masterClrMapping/>
+  </p:clrMapOvr>
+</p:sld>
+</file>
+
+<file path=ppt/slides/slide43.xml><?xml version="1.0" encoding="utf-8"?>
+<p:sld xmlns:a="http://schemas.openxmlformats.org/drawingml/2006/main" xmlns:p="http://schemas.openxmlformats.org/presentationml/2006/main" xmlns:r="http://schemas.openxmlformats.org/officeDocument/2006/relationships">
+  <p:cSld>
+    <p:spTree>
+      <p:nvGrpSpPr>
+        <p:cNvPr id="1" name=""/>
+        <p:cNvGrpSpPr/>
+        <p:nvPr/>
+      </p:nvGrpSpPr>
+      <p:grpSpPr/>
+      <p:sp>
+        <p:nvSpPr>
+          <p:cNvPr id="2" name="Title 1"/>
+          <p:cNvSpPr>
+            <a:spLocks noGrp="1"/>
+          </p:cNvSpPr>
+          <p:nvPr>
+            <p:ph type="title"/>
+          </p:nvPr>
+        </p:nvSpPr>
+        <p:spPr/>
+        <p:txBody>
+          <a:bodyPr/>
+          <a:lstStyle/>
+          <a:p>
+            <a:r>
+              <a:t>* Real-time Processing:  Instantaneous language understanding and generation.</a:t>
+            </a:r>
+          </a:p>
+        </p:txBody>
+      </p:sp>
+      <p:sp>
+        <p:nvSpPr>
+          <p:cNvPr id="3" name="Content Placeholder 2"/>
+          <p:cNvSpPr>
+            <a:spLocks noGrp="1"/>
+          </p:cNvSpPr>
+          <p:nvPr>
+            <p:ph idx="1"/>
+          </p:nvPr>
+        </p:nvSpPr>
+        <p:spPr/>
+        <p:txBody>
+          <a:bodyPr/>
+          <a:lstStyle/>
+          <a:p/>
+        </p:txBody>
+      </p:sp>
+    </p:spTree>
+  </p:cSld>
+  <p:clrMapOvr>
+    <a:masterClrMapping/>
+  </p:clrMapOvr>
+</p:sld>
+</file>
+
+<file path=ppt/slides/slide44.xml><?xml version="1.0" encoding="utf-8"?>
+<p:sld xmlns:a="http://schemas.openxmlformats.org/drawingml/2006/main" xmlns:p="http://schemas.openxmlformats.org/presentationml/2006/main" xmlns:r="http://schemas.openxmlformats.org/officeDocument/2006/relationships">
+  <p:cSld>
+    <p:spTree>
+      <p:nvGrpSpPr>
+        <p:cNvPr id="1" name=""/>
+        <p:cNvGrpSpPr/>
+        <p:nvPr/>
+      </p:nvGrpSpPr>
+      <p:grpSpPr/>
+      <p:sp>
+        <p:nvSpPr>
+          <p:cNvPr id="2" name="Title 1"/>
+          <p:cNvSpPr>
+            <a:spLocks noGrp="1"/>
+          </p:cNvSpPr>
+          <p:nvPr>
+            <p:ph type="title"/>
+          </p:nvPr>
+        </p:nvSpPr>
+        <p:spPr/>
+        <p:txBody>
+          <a:bodyPr/>
+          <a:lstStyle/>
+          <a:p>
+            <a:r>
+              <a:t>* Ethical Considerations: Bias in datasets, responsible AI development, and potential misuse. (Visual: showcase examples of multilingual applications, real-time applications and ethical dilemmas)</a:t>
+            </a:r>
+          </a:p>
+        </p:txBody>
+      </p:sp>
+      <p:sp>
+        <p:nvSpPr>
+          <p:cNvPr id="3" name="Content Placeholder 2"/>
+          <p:cNvSpPr>
+            <a:spLocks noGrp="1"/>
+          </p:cNvSpPr>
+          <p:nvPr>
+            <p:ph idx="1"/>
+          </p:nvPr>
+        </p:nvSpPr>
+        <p:spPr/>
+        <p:txBody>
+          <a:bodyPr/>
+          <a:lstStyle/>
+          <a:p/>
+        </p:txBody>
+      </p:sp>
+    </p:spTree>
+  </p:cSld>
+  <p:clrMapOvr>
+    <a:masterClrMapping/>
+  </p:clrMapOvr>
+</p:sld>
+</file>
+
+<file path=ppt/slides/slide45.xml><?xml version="1.0" encoding="utf-8"?>
+<p:sld xmlns:a="http://schemas.openxmlformats.org/drawingml/2006/main" xmlns:p="http://schemas.openxmlformats.org/presentationml/2006/main" xmlns:r="http://schemas.openxmlformats.org/officeDocument/2006/relationships">
+  <p:cSld>
+    <p:spTree>
+      <p:nvGrpSpPr>
+        <p:cNvPr id="1" name=""/>
+        <p:cNvGrpSpPr/>
+        <p:nvPr/>
+      </p:nvGrpSpPr>
+      <p:grpSpPr/>
+      <p:sp>
+        <p:nvSpPr>
+          <p:cNvPr id="2" name="Title 1"/>
+          <p:cNvSpPr>
+            <a:spLocks noGrp="1"/>
+          </p:cNvSpPr>
+          <p:nvPr>
+            <p:ph type="title"/>
+          </p:nvPr>
+        </p:nvSpPr>
+        <p:spPr/>
+        <p:txBody>
+          <a:bodyPr/>
+          <a:lstStyle/>
+          <a:p>
+            <a:r>
+              <a:t>**(Speaker Notes):** The future of NLP is bright. We're seeing a push towards multilingual models that can handle multiple languages seamlessly, and real-time processing is becoming increasingly important.  However, we must also consider the ethical implications. Biases in training data can lead to unfair or discriminatory outcomes. Responsible AI development is crucial to ensure that NLP technologies are used ethically and benefit society as a whole. (Discuss specific examples of bias, responsible AI initiatives, and potential misuse of NLP technology).</a:t>
+            </a:r>
+          </a:p>
+        </p:txBody>
+      </p:sp>
+      <p:sp>
+        <p:nvSpPr>
+          <p:cNvPr id="3" name="Content Placeholder 2"/>
+          <p:cNvSpPr>
+            <a:spLocks noGrp="1"/>
+          </p:cNvSpPr>
+          <p:nvPr>
+            <p:ph idx="1"/>
+          </p:nvPr>
+        </p:nvSpPr>
+        <p:spPr/>
+        <p:txBody>
+          <a:bodyPr/>
+          <a:lstStyle/>
+          <a:p/>
+        </p:txBody>
+      </p:sp>
+    </p:spTree>
+  </p:cSld>
+  <p:clrMapOvr>
+    <a:masterClrMapping/>
+  </p:clrMapOvr>
+</p:sld>
+</file>
+
+<file path=ppt/slides/slide46.xml><?xml version="1.0" encoding="utf-8"?>
+<p:sld xmlns:a="http://schemas.openxmlformats.org/drawingml/2006/main" xmlns:p="http://schemas.openxmlformats.org/presentationml/2006/main" xmlns:r="http://schemas.openxmlformats.org/officeDocument/2006/relationships">
+  <p:cSld>
+    <p:spTree>
+      <p:nvGrpSpPr>
+        <p:cNvPr id="1" name=""/>
+        <p:cNvGrpSpPr/>
+        <p:nvPr/>
+      </p:nvGrpSpPr>
+      <p:grpSpPr/>
+      <p:sp>
+        <p:nvSpPr>
+          <p:cNvPr id="2" name="Title 1"/>
+          <p:cNvSpPr>
+            <a:spLocks noGrp="1"/>
+          </p:cNvSpPr>
+          <p:nvPr>
+            <p:ph type="title"/>
+          </p:nvPr>
+        </p:nvSpPr>
+        <p:spPr/>
+        <p:txBody>
+          <a:bodyPr/>
+          <a:lstStyle/>
+          <a:p>
+            <a:r>
+              <a:t>**Slide 7: Conclusion &amp; Q&amp;A (5 minutes)**</a:t>
+            </a:r>
+          </a:p>
+        </p:txBody>
+      </p:sp>
+      <p:sp>
+        <p:nvSpPr>
+          <p:cNvPr id="3" name="Content Placeholder 2"/>
+          <p:cNvSpPr>
+            <a:spLocks noGrp="1"/>
+          </p:cNvSpPr>
+          <p:nvPr>
+            <p:ph idx="1"/>
+          </p:nvPr>
+        </p:nvSpPr>
+        <p:spPr/>
+        <p:txBody>
+          <a:bodyPr/>
+          <a:lstStyle/>
+          <a:p/>
+        </p:txBody>
+      </p:sp>
+    </p:spTree>
+  </p:cSld>
+  <p:clrMapOvr>
+    <a:masterClrMapping/>
+  </p:clrMapOvr>
+</p:sld>
+</file>
+
+<file path=ppt/slides/slide47.xml><?xml version="1.0" encoding="utf-8"?>
+<p:sld xmlns:a="http://schemas.openxmlformats.org/drawingml/2006/main" xmlns:p="http://schemas.openxmlformats.org/presentationml/2006/main" xmlns:r="http://schemas.openxmlformats.org/officeDocument/2006/relationships">
+  <p:cSld>
+    <p:spTree>
+      <p:nvGrpSpPr>
+        <p:cNvPr id="1" name=""/>
+        <p:cNvGrpSpPr/>
+        <p:nvPr/>
+      </p:nvGrpSpPr>
+      <p:grpSpPr/>
+      <p:sp>
+        <p:nvSpPr>
+          <p:cNvPr id="2" name="Title 1"/>
+          <p:cNvSpPr>
+            <a:spLocks noGrp="1"/>
+          </p:cNvSpPr>
+          <p:nvPr>
+            <p:ph type="title"/>
+          </p:nvPr>
+        </p:nvSpPr>
+        <p:spPr/>
+        <p:txBody>
+          <a:bodyPr/>
+          <a:lstStyle/>
+          <a:p>
+            <a:r>
+              <a:t>* **Title:**  Key Takeaways and Future Directions</a:t>
+            </a:r>
+          </a:p>
+        </p:txBody>
+      </p:sp>
+      <p:sp>
+        <p:nvSpPr>
+          <p:cNvPr id="3" name="Content Placeholder 2"/>
+          <p:cNvSpPr>
+            <a:spLocks noGrp="1"/>
+          </p:cNvSpPr>
+          <p:nvPr>
+            <p:ph idx="1"/>
+          </p:nvPr>
+        </p:nvSpPr>
+        <p:spPr/>
+        <p:txBody>
+          <a:bodyPr/>
+          <a:lstStyle/>
+          <a:p/>
+        </p:txBody>
+      </p:sp>
+    </p:spTree>
+  </p:cSld>
+  <p:clrMapOvr>
+    <a:masterClrMapping/>
+  </p:clrMapOvr>
+</p:sld>
+</file>
+
+<file path=ppt/slides/slide48.xml><?xml version="1.0" encoding="utf-8"?>
+<p:sld xmlns:a="http://schemas.openxmlformats.org/drawingml/2006/main" xmlns:p="http://schemas.openxmlformats.org/presentationml/2006/main" xmlns:r="http://schemas.openxmlformats.org/officeDocument/2006/relationships">
+  <p:cSld>
+    <p:spTree>
+      <p:nvGrpSpPr>
+        <p:cNvPr id="1" name=""/>
+        <p:cNvGrpSpPr/>
+        <p:nvPr/>
+      </p:nvGrpSpPr>
+      <p:grpSpPr/>
+      <p:sp>
+        <p:nvSpPr>
+          <p:cNvPr id="2" name="Title 1"/>
+          <p:cNvSpPr>
+            <a:spLocks noGrp="1"/>
+          </p:cNvSpPr>
+          <p:nvPr>
+            <p:ph type="title"/>
+          </p:nvPr>
+        </p:nvSpPr>
+        <p:spPr/>
+        <p:txBody>
+          <a:bodyPr/>
+          <a:lstStyle/>
+          <a:p>
+            <a:r>
+              <a:t>* **Bullet Points:**</a:t>
+            </a:r>
+          </a:p>
+        </p:txBody>
+      </p:sp>
+      <p:sp>
+        <p:nvSpPr>
+          <p:cNvPr id="3" name="Content Placeholder 2"/>
+          <p:cNvSpPr>
+            <a:spLocks noGrp="1"/>
+          </p:cNvSpPr>
+          <p:nvPr>
+            <p:ph idx="1"/>
+          </p:nvPr>
+        </p:nvSpPr>
+        <p:spPr/>
+        <p:txBody>
+          <a:bodyPr/>
+          <a:lstStyle/>
+          <a:p/>
+        </p:txBody>
+      </p:sp>
+    </p:spTree>
+  </p:cSld>
+  <p:clrMapOvr>
+    <a:masterClrMapping/>
+  </p:clrMapOvr>
+</p:sld>
+</file>
+
+<file path=ppt/slides/slide49.xml><?xml version="1.0" encoding="utf-8"?>
+<p:sld xmlns:a="http://schemas.openxmlformats.org/drawingml/2006/main" xmlns:p="http://schemas.openxmlformats.org/presentationml/2006/main" xmlns:r="http://schemas.openxmlformats.org/officeDocument/2006/relationships">
+  <p:cSld>
+    <p:spTree>
+      <p:nvGrpSpPr>
+        <p:cNvPr id="1" name=""/>
+        <p:cNvGrpSpPr/>
+        <p:nvPr/>
+      </p:nvGrpSpPr>
+      <p:grpSpPr/>
+      <p:sp>
+        <p:nvSpPr>
+          <p:cNvPr id="2" name="Title 1"/>
+          <p:cNvSpPr>
+            <a:spLocks noGrp="1"/>
+          </p:cNvSpPr>
+          <p:nvPr>
+            <p:ph type="title"/>
+          </p:nvPr>
+        </p:nvSpPr>
+        <p:spPr/>
+        <p:txBody>
+          <a:bodyPr/>
+          <a:lstStyle/>
+          <a:p>
+            <a:r>
+              <a:t>* Summary of key concepts discussed.</a:t>
+            </a:r>
+          </a:p>
+        </p:txBody>
+      </p:sp>
+      <p:sp>
+        <p:nvSpPr>
+          <p:cNvPr id="3" name="Content Placeholder 2"/>
+          <p:cNvSpPr>
+            <a:spLocks noGrp="1"/>
+          </p:cNvSpPr>
+          <p:nvPr>
+            <p:ph idx="1"/>
+          </p:nvPr>
+        </p:nvSpPr>
+        <p:spPr/>
+        <p:txBody>
+          <a:bodyPr/>
+          <a:lstStyle/>
+          <a:p/>
         </p:txBody>
       </p:sp>
     </p:spTree>
@@ -3778,7 +5628,7 @@
           <a:lstStyle/>
           <a:p>
             <a:r>
-              <a:t>NLP Pipeline (Simplified)</a:t>
+              <a:t>* **Title:** Natural Language Processing: Understanding and Shaping Human-Computer Interaction</a:t>
             </a:r>
           </a:p>
         </p:txBody>
@@ -3797,26 +5647,175 @@
         <p:txBody>
           <a:bodyPr/>
           <a:lstStyle/>
-          <a:p>
-            <a:r>
-              <a:t>1. Text Preprocessing</a:t>
-            </a:r>
-          </a:p>
-          <a:p>
-            <a:r>
-              <a:t>2. Feature Extraction</a:t>
-            </a:r>
-          </a:p>
-          <a:p>
-            <a:r>
-              <a:t>3. Model Training</a:t>
-            </a:r>
-          </a:p>
-          <a:p>
-            <a:r>
-              <a:t>4. Output/Prediction</a:t>
-            </a:r>
-          </a:p>
+          <a:p/>
+        </p:txBody>
+      </p:sp>
+    </p:spTree>
+  </p:cSld>
+  <p:clrMapOvr>
+    <a:masterClrMapping/>
+  </p:clrMapOvr>
+</p:sld>
+</file>
+
+<file path=ppt/slides/slide50.xml><?xml version="1.0" encoding="utf-8"?>
+<p:sld xmlns:a="http://schemas.openxmlformats.org/drawingml/2006/main" xmlns:p="http://schemas.openxmlformats.org/presentationml/2006/main" xmlns:r="http://schemas.openxmlformats.org/officeDocument/2006/relationships">
+  <p:cSld>
+    <p:spTree>
+      <p:nvGrpSpPr>
+        <p:cNvPr id="1" name=""/>
+        <p:cNvGrpSpPr/>
+        <p:nvPr/>
+      </p:nvGrpSpPr>
+      <p:grpSpPr/>
+      <p:sp>
+        <p:nvSpPr>
+          <p:cNvPr id="2" name="Title 1"/>
+          <p:cNvSpPr>
+            <a:spLocks noGrp="1"/>
+          </p:cNvSpPr>
+          <p:nvPr>
+            <p:ph type="title"/>
+          </p:nvPr>
+        </p:nvSpPr>
+        <p:spPr/>
+        <p:txBody>
+          <a:bodyPr/>
+          <a:lstStyle/>
+          <a:p>
+            <a:r>
+              <a:t>* NLP’s transformative impact across various industries.</a:t>
+            </a:r>
+          </a:p>
+        </p:txBody>
+      </p:sp>
+      <p:sp>
+        <p:nvSpPr>
+          <p:cNvPr id="3" name="Content Placeholder 2"/>
+          <p:cNvSpPr>
+            <a:spLocks noGrp="1"/>
+          </p:cNvSpPr>
+          <p:nvPr>
+            <p:ph idx="1"/>
+          </p:nvPr>
+        </p:nvSpPr>
+        <p:spPr/>
+        <p:txBody>
+          <a:bodyPr/>
+          <a:lstStyle/>
+          <a:p/>
+        </p:txBody>
+      </p:sp>
+    </p:spTree>
+  </p:cSld>
+  <p:clrMapOvr>
+    <a:masterClrMapping/>
+  </p:clrMapOvr>
+</p:sld>
+</file>
+
+<file path=ppt/slides/slide51.xml><?xml version="1.0" encoding="utf-8"?>
+<p:sld xmlns:a="http://schemas.openxmlformats.org/drawingml/2006/main" xmlns:p="http://schemas.openxmlformats.org/presentationml/2006/main" xmlns:r="http://schemas.openxmlformats.org/officeDocument/2006/relationships">
+  <p:cSld>
+    <p:spTree>
+      <p:nvGrpSpPr>
+        <p:cNvPr id="1" name=""/>
+        <p:cNvGrpSpPr/>
+        <p:nvPr/>
+      </p:nvGrpSpPr>
+      <p:grpSpPr/>
+      <p:sp>
+        <p:nvSpPr>
+          <p:cNvPr id="2" name="Title 1"/>
+          <p:cNvSpPr>
+            <a:spLocks noGrp="1"/>
+          </p:cNvSpPr>
+          <p:nvPr>
+            <p:ph type="title"/>
+          </p:nvPr>
+        </p:nvSpPr>
+        <p:spPr/>
+        <p:txBody>
+          <a:bodyPr/>
+          <a:lstStyle/>
+          <a:p>
+            <a:r>
+              <a:t>* Open discussion and Q&amp;A.</a:t>
+            </a:r>
+          </a:p>
+        </p:txBody>
+      </p:sp>
+      <p:sp>
+        <p:nvSpPr>
+          <p:cNvPr id="3" name="Content Placeholder 2"/>
+          <p:cNvSpPr>
+            <a:spLocks noGrp="1"/>
+          </p:cNvSpPr>
+          <p:nvPr>
+            <p:ph idx="1"/>
+          </p:nvPr>
+        </p:nvSpPr>
+        <p:spPr/>
+        <p:txBody>
+          <a:bodyPr/>
+          <a:lstStyle/>
+          <a:p/>
+        </p:txBody>
+      </p:sp>
+    </p:spTree>
+  </p:cSld>
+  <p:clrMapOvr>
+    <a:masterClrMapping/>
+  </p:clrMapOvr>
+</p:sld>
+</file>
+
+<file path=ppt/slides/slide52.xml><?xml version="1.0" encoding="utf-8"?>
+<p:sld xmlns:a="http://schemas.openxmlformats.org/drawingml/2006/main" xmlns:p="http://schemas.openxmlformats.org/presentationml/2006/main" xmlns:r="http://schemas.openxmlformats.org/officeDocument/2006/relationships">
+  <p:cSld>
+    <p:spTree>
+      <p:nvGrpSpPr>
+        <p:cNvPr id="1" name=""/>
+        <p:cNvGrpSpPr/>
+        <p:nvPr/>
+      </p:nvGrpSpPr>
+      <p:grpSpPr/>
+      <p:sp>
+        <p:nvSpPr>
+          <p:cNvPr id="2" name="Title 1"/>
+          <p:cNvSpPr>
+            <a:spLocks noGrp="1"/>
+          </p:cNvSpPr>
+          <p:nvPr>
+            <p:ph type="title"/>
+          </p:nvPr>
+        </p:nvSpPr>
+        <p:spPr/>
+        <p:txBody>
+          <a:bodyPr/>
+          <a:lstStyle/>
+          <a:p>
+            <a:r>
+              <a:t>**(Speaker Notes):** In conclusion, NLP is a powerful and rapidly evolving field with vast potential.  We've explored its core components, techniques, challenges, and future directions.  It's impacting numerous industries and will continue to shape our interaction with technology.  Now, I'd be happy to answer any questions you may have. (Open the floor for questions and discussion).</a:t>
+            </a:r>
+          </a:p>
+        </p:txBody>
+      </p:sp>
+      <p:sp>
+        <p:nvSpPr>
+          <p:cNvPr id="3" name="Content Placeholder 2"/>
+          <p:cNvSpPr>
+            <a:spLocks noGrp="1"/>
+          </p:cNvSpPr>
+          <p:nvPr>
+            <p:ph idx="1"/>
+          </p:nvPr>
+        </p:nvSpPr>
+        <p:spPr/>
+        <p:txBody>
+          <a:bodyPr/>
+          <a:lstStyle/>
+          <a:p/>
         </p:txBody>
       </p:sp>
     </p:spTree>
@@ -3853,7 +5852,7 @@
           <a:lstStyle/>
           <a:p>
             <a:r>
-              <a:t>Text Preprocessing</a:t>
+              <a:t>* **Subtitle:** A Journey into the World of Text and Speech Understanding</a:t>
             </a:r>
           </a:p>
         </p:txBody>
@@ -3873,38 +5872,6 @@
           <a:bodyPr/>
           <a:lstStyle/>
           <a:p/>
-          <a:p>
-            <a:pPr>
-              <a:defRPr sz="1800"/>
-            </a:pPr>
-            <a:r>
-              <a:t>Tokenization: Breaking down text into individual words or sub-word units.</a:t>
-            </a:r>
-          </a:p>
-          <a:p>
-            <a:pPr>
-              <a:defRPr sz="1800"/>
-            </a:pPr>
-            <a:r>
-              <a:t>Stop Word Removal: Removing common words that don't carry much meaning.</a:t>
-            </a:r>
-          </a:p>
-          <a:p>
-            <a:pPr>
-              <a:defRPr sz="1800"/>
-            </a:pPr>
-            <a:r>
-              <a:t>Stemming/Lemmatization: Reducing words to their root form.</a:t>
-            </a:r>
-          </a:p>
-          <a:p>
-            <a:pPr>
-              <a:defRPr sz="1800"/>
-            </a:pPr>
-            <a:r>
-              <a:t>Cleaning: Handling punctuation, special characters, and noise.</a:t>
-            </a:r>
-          </a:p>
         </p:txBody>
       </p:sp>
     </p:spTree>
@@ -3941,7 +5908,7 @@
           <a:lstStyle/>
           <a:p>
             <a:r>
-              <a:t>Feature Extraction</a:t>
+              <a:t>* **Your Name &amp; Affiliation**</a:t>
             </a:r>
           </a:p>
         </p:txBody>
@@ -3961,38 +5928,6 @@
           <a:bodyPr/>
           <a:lstStyle/>
           <a:p/>
-          <a:p>
-            <a:pPr>
-              <a:defRPr sz="1800"/>
-            </a:pPr>
-            <a:r>
-              <a:t>Bag-of-Words (BoW): Representing text as a collection of words and their frequencies.</a:t>
-            </a:r>
-          </a:p>
-          <a:p>
-            <a:pPr>
-              <a:defRPr sz="1800"/>
-            </a:pPr>
-            <a:r>
-              <a:t>TF-IDF: Weighing words based on their importance in the document.</a:t>
-            </a:r>
-          </a:p>
-          <a:p>
-            <a:pPr>
-              <a:defRPr sz="1800"/>
-            </a:pPr>
-            <a:r>
-              <a:t>Word Embeddings (Word2Vec, GloVe, FastText): Representing words as dense vectors.</a:t>
-            </a:r>
-          </a:p>
-          <a:p>
-            <a:pPr>
-              <a:defRPr sz="1800"/>
-            </a:pPr>
-            <a:r>
-              <a:t>Contextualized Embeddings (BERT, ELMo): Embeddings that consider the context of a word.</a:t>
-            </a:r>
-          </a:p>
         </p:txBody>
       </p:sp>
     </p:spTree>
@@ -4029,7 +5964,7 @@
           <a:lstStyle/>
           <a:p>
             <a:r>
-              <a:t>Machine Learning Models in NLP</a:t>
+              <a:t>* **Date**</a:t>
             </a:r>
           </a:p>
         </p:txBody>
@@ -4049,46 +5984,6 @@
           <a:bodyPr/>
           <a:lstStyle/>
           <a:p/>
-          <a:p>
-            <a:pPr>
-              <a:defRPr sz="1800"/>
-            </a:pPr>
-            <a:r>
-              <a:t>Naive Bayes: A probabilistic classifier used for text classification.</a:t>
-            </a:r>
-          </a:p>
-          <a:p>
-            <a:pPr>
-              <a:defRPr sz="1800"/>
-            </a:pPr>
-            <a:r>
-              <a:t>Support Vector Machines (SVMs): Effective for text classification and NER.</a:t>
-            </a:r>
-          </a:p>
-          <a:p>
-            <a:pPr>
-              <a:defRPr sz="1800"/>
-            </a:pPr>
-            <a:r>
-              <a:t>Recurrent Neural Networks (RNNs): Suitable for sequential data.</a:t>
-            </a:r>
-          </a:p>
-          <a:p>
-            <a:pPr>
-              <a:defRPr sz="1800"/>
-            </a:pPr>
-            <a:r>
-              <a:t>Long Short-Term Memory (LSTM) networks: A type of RNN that addresses the vanishing gradient problem.</a:t>
-            </a:r>
-          </a:p>
-          <a:p>
-            <a:pPr>
-              <a:defRPr sz="1800"/>
-            </a:pPr>
-            <a:r>
-              <a:t>Transformers (BERT, GPT): Powerful models based on the Transformer architecture.</a:t>
-            </a:r>
-          </a:p>
         </p:txBody>
       </p:sp>
     </p:spTree>
@@ -4125,7 +6020,7 @@
           <a:lstStyle/>
           <a:p>
             <a:r>
-              <a:t>Deep Learning and NLP</a:t>
+              <a:t>**(Speaker Notes):** Good morning, everyone. Welcome to this lecture on Natural Language Processing.  Over the next hour, we'll explore the fascinating field of NLP, examining its core components, practical applications, and future directions.  This field is rapidly evolving, impacting how we interact with technology daily. Let's dive in!  (Transition to next slide)</a:t>
             </a:r>
           </a:p>
         </p:txBody>
@@ -4144,21 +6039,7 @@
         <p:txBody>
           <a:bodyPr/>
           <a:lstStyle/>
-          <a:p>
-            <a:r>
-              <a:t>Deep learning has revolutionized NLP, leading to significant improvements in accuracy and performance.</a:t>
-            </a:r>
-          </a:p>
-          <a:p>
-            <a:r>
-              <a:t>Neural networks, particularly recurrent and transformer networks, are widely used.</a:t>
-            </a:r>
-          </a:p>
-          <a:p>
-            <a:r>
-              <a:t>Transfer learning and pre-trained models (like BERT) allow for faster training.</a:t>
-            </a:r>
-          </a:p>
+          <a:p/>
         </p:txBody>
       </p:sp>
     </p:spTree>

</xml_diff>